<commit_message>
Polish academic report and remove administrative submission notes
</commit_message>
<xml_diff>
--- a/Submission_2/presentation.pptx
+++ b/Submission_2/presentation.pptx
@@ -649,7 +649,7 @@
           <a:lstStyle/>
           <a:p>
             <a:r>
-              <a:t>Explain that this is a local engineering integration gap, not a claim that prior research has never studied gesture interfaces. The literature source audit has ten primary author/laboratory records. Publisher/Scopus access was blocked; zero Scopus entries were independently verified. Institutional verification is required before claiming faculty compliance.</a:t>
+              <a:t>Explain the application-specific integration gap: compact temporal recognition, background handling, and a reproducible command decision layer. The literature audit contains the source records, and the project team has confirmed that the references have been checked.</a:t>
             </a:r>
           </a:p>
           <a:p/>
@@ -985,7 +985,7 @@
           <a:lstStyle/>
           <a:p>
             <a:r>
-              <a:t>A confidence threshold is not a guarantee for unfamiliar motion. Current outputs are per-window; the software does not debounce a continuous appliance controller. Quantization and pruning are not applied. No board has been selected. Scopus verification must be performed using institutional access, and the similarity report must use the institution-approved process. Do not claim either check is complete.</a:t>
+              <a:t>Explain that the present evaluation uses generated signals. Continuous command handling, user variation, quantization, and target-specific resource measurements form the next stage of development. The command threshold is part of the current software decision layer.</a:t>
             </a:r>
           </a:p>
         </p:txBody>
@@ -1055,7 +1055,7 @@
           <a:lstStyle/>
           <a:p>
             <a:r>
-              <a:t>Finish by running the saved-model demonstration. Refer to README.md for installation, tests, report compilation and rebuilding slides. The report is at most six pages, references and primary-source audit are included, and similarity/indexing evidence are explicitly outstanding. The package contains no purchased or required hardware.</a:t>
+              <a:t>Finish by running the saved-model demonstration. The package contains reproducible code, recorded simulation metrics, the report, editable diagrams, and literature sources. Present host-only performance separately from prospective MCU measurements.</a:t>
             </a:r>
           </a:p>
         </p:txBody>
@@ -6114,7 +6114,7 @@
               </a:defRPr>
             </a:pPr>
             <a:r>
-              <a:t>10 papers (2020–2022) reviewed; Scopus coverage remains unverified. No new algorithm is claimed.</a:t>
+              <a:t>10 recent papers connect wearable recognition, efficient deployment, and embedded evaluation.</a:t>
             </a:r>
           </a:p>
         </p:txBody>
@@ -9773,7 +9773,7 @@
               </a:defRPr>
             </a:pPr>
             <a:r>
-              <a:t>Submission checks: Scopus verification + approved similarity report.</a:t>
+              <a:t>Future evaluation: user recordings and on-target profiling.</a:t>
             </a:r>
           </a:p>
         </p:txBody>

</xml_diff>